<commit_message>
Fix oversized-image overflow in report and slides
complete_erd.png (and other diagrams) were inserted at a fixed width
without checking aspect ratio, so the very tall complete_erd.png
(0.47 w/h) overflowed past the page/slide bounds and got clipped.
Both generators now size images by actual aspect ratio, capped to
fit within the page/slide, so every diagram renders fully visible.

Co-Authored-By: Claude Sonnet 5 <noreply@anthropic.com>
</commit_message>
<xml_diff>
--- a/assignment/Slide_BaoCao_QLBenhVien.pptx
+++ b/assignment/Slide_BaoCao_QLBenhVien.pptx
@@ -7084,8 +7084,8 @@
         </p:blipFill>
         <p:spPr>
           <a:xfrm>
-            <a:off x="1752447" y="1280160"/>
-            <a:ext cx="8686800" cy="18417006"/>
+            <a:off x="4845084" y="1280160"/>
+            <a:ext cx="2501525" cy="5303520"/>
           </a:xfrm>
           <a:prstGeom prst="rect">
             <a:avLst/>
@@ -7247,8 +7247,8 @@
         </p:blipFill>
         <p:spPr>
           <a:xfrm>
-            <a:off x="2438247" y="1280160"/>
-            <a:ext cx="7315200" cy="6922262"/>
+            <a:off x="3293561" y="1280160"/>
+            <a:ext cx="5604571" cy="5303520"/>
           </a:xfrm>
           <a:prstGeom prst="rect">
             <a:avLst/>
@@ -7410,8 +7410,8 @@
         </p:blipFill>
         <p:spPr>
           <a:xfrm>
-            <a:off x="2438247" y="1280160"/>
-            <a:ext cx="7315200" cy="6946900"/>
+            <a:off x="3303500" y="1280160"/>
+            <a:ext cx="5584693" cy="5303520"/>
           </a:xfrm>
           <a:prstGeom prst="rect">
             <a:avLst/>
@@ -7573,8 +7573,8 @@
         </p:blipFill>
         <p:spPr>
           <a:xfrm>
-            <a:off x="1981047" y="1280160"/>
-            <a:ext cx="8229600" cy="8985338"/>
+            <a:off x="3667121" y="1280160"/>
+            <a:ext cx="4857452" cy="5303520"/>
           </a:xfrm>
           <a:prstGeom prst="rect">
             <a:avLst/>

</xml_diff>